<commit_message>
PART 24: strip module is a separable KxK kernel, not a strip; fix schematic
Measured: each MultiScaleStrip branch (1xK then Kx1, depthwise, in sequence)
has a full KxK footprint (rank-1 filter). Schematic wording corrected.

Co-Authored-By: Claude Opus 5.5 <noreply@anthropic.com>
Claude-Session: https://claude.ai/code/session_0125kNUJSvGZTKpq5m35Ucid
</commit_message>
<xml_diff>
--- a/Hybrid_Model_Schematic.pptx
+++ b/Hybrid_Model_Schematic.pptx
@@ -24635,7 +24635,7 @@
                 </a:solidFill>
                 <a:latin typeface="Calibri"/>
               </a:rPr>
-              <a:t> — long thin filters (enc. 1–3, bottleneck)</a:t>
+              <a:t> — wide 7/11/21-px windows (enc. 1–3, bottleneck)</a:t>
             </a:r>
           </a:p>
           <a:p>
@@ -25173,7 +25173,7 @@
                 </a:solidFill>
                 <a:latin typeface="Calibri"/>
               </a:rPr>
-              <a:t>Looks along long thin lines of 7, 11 and 21 pixels, in time and in frequency.</a:t>
+              <a:t>Looks at wider areas (7, 11, 21 px) cheaply: a thin filter along frequency, then one along time.</a:t>
             </a:r>
           </a:p>
         </p:txBody>
@@ -27237,7 +27237,7 @@
                   </a:solidFill>
                   <a:latin typeface="Calibri"/>
                 </a:rPr>
-                <a:t>On LOFAR (rows = time): 1×K runs along frequency (catches broadband bursts) · K×1 runs along time (catches narrowband lines)</a:t>
+                <a:t>Each path = 1×K along frequency, then K×1 along time → together it covers a K×K square (measured)</a:t>
               </a:r>
             </a:p>
           </p:txBody>

</xml_diff>

<commit_message>
Schematic: full accuracy pass against code and measured results
- slide 1: say it is drawn at our sizes; state tf_unet's real shape
  (2 pools, 32->128, 465,986 params, 512 in -> 472 out)
- slide 2: class weighting is not a difference from tf_unet; ECA not in
  bottleneck; tf_unet contrasts for 4-7; red = added modules, not RFI-specific
- slide 3: add Dropout; shortcut is always a 1x1 conv in this model
- slide 4: add input scaling and validation checkpointing; label the score
  as best-threshold F1; drop the retracted GroupNorm claim; tf_unet comparison
- context doc PART 24.1 records the corrections

Co-Authored-By: Claude Opus 5.5 <noreply@anthropic.com>
Claude-Session: https://claude.ai/code/session_0125kNUJSvGZTKpq5m35Ucid
</commit_message>
<xml_diff>
--- a/Hybrid_Model_Schematic.pptx
+++ b/Hybrid_Model_Schematic.pptx
@@ -23112,6 +23112,102 @@
           </a:p>
         </p:txBody>
       </p:sp>
+      <p:sp>
+        <p:nvSpPr>
+          <p:cNvPr id="38" name="Rounded Rectangle 37"/>
+          <p:cNvSpPr/>
+          <p:nvPr/>
+        </p:nvSpPr>
+        <p:spPr>
+          <a:xfrm>
+            <a:off x="685800" y="6144768"/>
+            <a:ext cx="10835640" cy="384048"/>
+          </a:xfrm>
+          <a:prstGeom prst="roundRect">
+            <a:avLst>
+              <a:gd name="adj" fmla="val 6000"/>
+            </a:avLst>
+          </a:prstGeom>
+          <a:solidFill>
+            <a:srgbClr val="FBE3E7"/>
+          </a:solidFill>
+          <a:ln w="12700">
+            <a:solidFill>
+              <a:srgbClr val="D9DDE4"/>
+            </a:solidFill>
+          </a:ln>
+          <a:effectLst/>
+        </p:spPr>
+        <p:style>
+          <a:lnRef idx="1">
+            <a:schemeClr val="accent1"/>
+          </a:lnRef>
+          <a:fillRef idx="3">
+            <a:schemeClr val="accent1"/>
+          </a:fillRef>
+          <a:effectRef idx="2">
+            <a:schemeClr val="accent1"/>
+          </a:effectRef>
+          <a:fontRef idx="minor">
+            <a:schemeClr val="lt1"/>
+          </a:fontRef>
+        </p:style>
+        <p:txBody>
+          <a:bodyPr rtlCol="0" anchor="ctr"/>
+          <a:lstStyle/>
+          <a:p>
+            <a:pPr algn="ctr"/>
+          </a:p>
+        </p:txBody>
+      </p:sp>
+      <p:sp>
+        <p:nvSpPr>
+          <p:cNvPr id="39" name="TextBox 38"/>
+          <p:cNvSpPr txBox="1"/>
+          <p:nvPr/>
+        </p:nvSpPr>
+        <p:spPr>
+          <a:xfrm>
+            <a:off x="804672" y="6172200"/>
+            <a:ext cx="10607040" cy="329184"/>
+          </a:xfrm>
+          <a:prstGeom prst="rect">
+            <a:avLst/>
+          </a:prstGeom>
+          <a:noFill/>
+        </p:spPr>
+        <p:txBody>
+          <a:bodyPr wrap="square" anchor="ctr" lIns="27432" rIns="27432" tIns="9144" bIns="9144">
+            <a:spAutoFit/>
+          </a:bodyPr>
+          <a:lstStyle/>
+          <a:p>
+            <a:pPr algn="l">
+              <a:spcAft>
+                <a:spcPts val="200"/>
+              </a:spcAft>
+            </a:pPr>
+            <a:r>
+              <a:rPr sz="1000" b="1">
+                <a:solidFill>
+                  <a:srgbClr val="E31837"/>
+                </a:solidFill>
+                <a:latin typeface="Calibri"/>
+              </a:rPr>
+              <a:t>Drawn at our model's sizes so slides 1 and 2 line up box for box. </a:t>
+            </a:r>
+            <a:r>
+              <a:rPr sz="1000" b="0">
+                <a:solidFill>
+                  <a:srgbClr val="1E1E1E"/>
+                </a:solidFill>
+                <a:latin typeface="Calibri"/>
+              </a:rPr>
+              <a:t>Akeret's tf_unet (our baseline) is this design, but shrinks only twice (32 → 64 → 128 channels, 465,986 parameters) and trims the border, so 512 × 512 in gives 472 × 472 out.</a:t>
+            </a:r>
+          </a:p>
+        </p:txBody>
+      </p:sp>
     </p:spTree>
   </p:cSld>
   <p:clrMapOvr>
@@ -23152,7 +23248,7 @@
                 </a:solidFill>
                 <a:latin typeface="Calibri"/>
               </a:rPr>
-              <a:t>➢ Our model: the same U, with 9 changes</a:t>
+              <a:t>➢ Our model: the same U, changed inside</a:t>
             </a:r>
           </a:p>
         </p:txBody>
@@ -23205,7 +23301,7 @@
                   </a:solidFill>
                   <a:latin typeface="Calibri"/>
                 </a:rPr>
-                <a:t>▼ Input: spectrogram, 1 × 512 × 512 — sizes never shrink ⑦</a:t>
+                <a:t>▼ Input: spectrogram, 1 × 512 × 512 — no border trimming ⑦</a:t>
               </a:r>
             </a:p>
           </p:txBody>
@@ -24553,7 +24649,7 @@
         <p:spPr>
           <a:xfrm>
             <a:off x="685800" y="4937760"/>
-            <a:ext cx="3383280" cy="1417320"/>
+            <a:ext cx="3383280" cy="1572768"/>
           </a:xfrm>
           <a:prstGeom prst="roundRect">
             <a:avLst>
@@ -24601,7 +24697,7 @@
         <p:spPr>
           <a:xfrm>
             <a:off x="804672" y="4983480"/>
-            <a:ext cx="3182112" cy="1353312"/>
+            <a:ext cx="3182112" cy="1508760"/>
           </a:xfrm>
           <a:prstGeom prst="rect">
             <a:avLst/>
@@ -24616,11 +24712,11 @@
           <a:p>
             <a:pPr algn="l">
               <a:spcAft>
-                <a:spcPts val="300"/>
+                <a:spcPts val="200"/>
               </a:spcAft>
             </a:pPr>
             <a:r>
-              <a:rPr sz="1050" b="1">
+              <a:rPr sz="1000" b="1">
                 <a:solidFill>
                   <a:srgbClr val="E31837"/>
                 </a:solidFill>
@@ -24629,23 +24725,23 @@
               <a:t>① Strip convolutions</a:t>
             </a:r>
             <a:r>
-              <a:rPr sz="1050" b="0">
+              <a:rPr sz="1000" b="0">
                 <a:solidFill>
                   <a:srgbClr val="1E1E1E"/>
                 </a:solidFill>
                 <a:latin typeface="Calibri"/>
               </a:rPr>
-              <a:t> — wide 7/11/21-px windows (enc. 1–3, bottleneck)</a:t>
+              <a:t> — 7/11/21-px windows (enc. 1–3, bottleneck)</a:t>
             </a:r>
           </a:p>
           <a:p>
             <a:pPr algn="l">
               <a:spcAft>
-                <a:spcPts val="300"/>
+                <a:spcPts val="200"/>
               </a:spcAft>
             </a:pPr>
             <a:r>
-              <a:rPr sz="1050" b="1">
+              <a:rPr sz="1000" b="1">
                 <a:solidFill>
                   <a:srgbClr val="E31837"/>
                 </a:solidFill>
@@ -24654,7 +24750,7 @@
               <a:t>② Residual shortcut</a:t>
             </a:r>
             <a:r>
-              <a:rPr sz="1050" b="0">
+              <a:rPr sz="1000" b="0">
                 <a:solidFill>
                   <a:srgbClr val="1E1E1E"/>
                 </a:solidFill>
@@ -24666,11 +24762,11 @@
           <a:p>
             <a:pPr algn="l">
               <a:spcAft>
-                <a:spcPts val="300"/>
+                <a:spcPts val="200"/>
               </a:spcAft>
             </a:pPr>
             <a:r>
-              <a:rPr sz="1050" b="1">
+              <a:rPr sz="1000" b="1">
                 <a:solidFill>
                   <a:srgbClr val="E31837"/>
                 </a:solidFill>
@@ -24679,23 +24775,23 @@
               <a:t>③ ECA attention</a:t>
             </a:r>
             <a:r>
-              <a:rPr sz="1050" b="0">
+              <a:rPr sz="1000" b="0">
                 <a:solidFill>
                   <a:srgbClr val="1E1E1E"/>
                 </a:solidFill>
                 <a:latin typeface="Calibri"/>
               </a:rPr>
-              <a:t> — re-weights channels, every level</a:t>
+              <a:t> — after every encoder and decoder block</a:t>
             </a:r>
           </a:p>
           <a:p>
             <a:pPr algn="l">
               <a:spcAft>
-                <a:spcPts val="300"/>
+                <a:spcPts val="200"/>
               </a:spcAft>
             </a:pPr>
             <a:r>
-              <a:rPr sz="1050" b="1">
+              <a:rPr sz="1000" b="1">
                 <a:solidFill>
                   <a:srgbClr val="0F2043"/>
                 </a:solidFill>
@@ -24704,23 +24800,23 @@
               <a:t>④ GroupNorm</a:t>
             </a:r>
             <a:r>
-              <a:rPr sz="1050" b="0">
+              <a:rPr sz="1000" b="0">
                 <a:solidFill>
                   <a:srgbClr val="1E1E1E"/>
                 </a:solidFill>
                 <a:latin typeface="Calibri"/>
               </a:rPr>
-              <a:t> — inside every block</a:t>
+              <a:t> — in every ResBlock and strip (tf_unet: none)</a:t>
             </a:r>
           </a:p>
           <a:p>
             <a:pPr algn="l">
               <a:spcAft>
-                <a:spcPts val="300"/>
+                <a:spcPts val="200"/>
               </a:spcAft>
             </a:pPr>
             <a:r>
-              <a:rPr sz="1050" b="1">
+              <a:rPr sz="1000" b="1">
                 <a:solidFill>
                   <a:srgbClr val="0F2043"/>
                 </a:solidFill>
@@ -24729,13 +24825,13 @@
               <a:t>⑤ Raw scores</a:t>
             </a:r>
             <a:r>
-              <a:rPr sz="1050" b="0">
+              <a:rPr sz="1000" b="0">
                 <a:solidFill>
                   <a:srgbClr val="1E1E1E"/>
                 </a:solidFill>
                 <a:latin typeface="Calibri"/>
               </a:rPr>
-              <a:t> — no ReLU before softmax</a:t>
+              <a:t> — no ReLU before softmax (tf_unet has one)</a:t>
             </a:r>
           </a:p>
         </p:txBody>
@@ -24749,7 +24845,7 @@
         <p:spPr>
           <a:xfrm>
             <a:off x="8138160" y="4937760"/>
-            <a:ext cx="3383280" cy="1417320"/>
+            <a:ext cx="3383280" cy="1572768"/>
           </a:xfrm>
           <a:prstGeom prst="roundRect">
             <a:avLst>
@@ -24797,7 +24893,7 @@
         <p:spPr>
           <a:xfrm>
             <a:off x="8257031" y="4983480"/>
-            <a:ext cx="3182112" cy="1353312"/>
+            <a:ext cx="3182112" cy="1508760"/>
           </a:xfrm>
           <a:prstGeom prst="rect">
             <a:avLst/>
@@ -24812,11 +24908,11 @@
           <a:p>
             <a:pPr algn="l">
               <a:spcAft>
-                <a:spcPts val="300"/>
+                <a:spcPts val="200"/>
               </a:spcAft>
             </a:pPr>
             <a:r>
-              <a:rPr sz="1050" b="1">
+              <a:rPr sz="1000" b="1">
                 <a:solidFill>
                   <a:srgbClr val="0F2043"/>
                 </a:solidFill>
@@ -24825,23 +24921,23 @@
               <a:t>⑥ Dice + cross-entropy loss</a:t>
             </a:r>
             <a:r>
-              <a:rPr sz="1050" b="0">
+              <a:rPr sz="1000" b="0">
                 <a:solidFill>
                   <a:srgbClr val="1E1E1E"/>
                 </a:solidFill>
                 <a:latin typeface="Calibri"/>
               </a:rPr>
-              <a:t> (training)</a:t>
+              <a:t> (tf_unet: cross-entropy only)</a:t>
             </a:r>
           </a:p>
           <a:p>
             <a:pPr algn="l">
               <a:spcAft>
-                <a:spcPts val="300"/>
+                <a:spcPts val="200"/>
               </a:spcAft>
             </a:pPr>
             <a:r>
-              <a:rPr sz="1050" b="1">
+              <a:rPr sz="1000" b="1">
                 <a:solidFill>
                   <a:srgbClr val="0F2043"/>
                 </a:solidFill>
@@ -24850,7 +24946,7 @@
               <a:t>⑦ Same padding</a:t>
             </a:r>
             <a:r>
-              <a:rPr sz="1050" b="0">
+              <a:rPr sz="1000" b="0">
                 <a:solidFill>
                   <a:srgbClr val="1E1E1E"/>
                 </a:solidFill>
@@ -24862,11 +24958,11 @@
           <a:p>
             <a:pPr algn="l">
               <a:spcAft>
-                <a:spcPts val="300"/>
+                <a:spcPts val="200"/>
               </a:spcAft>
             </a:pPr>
             <a:r>
-              <a:rPr sz="1050" b="1">
+              <a:rPr sz="1000" b="1">
                 <a:solidFill>
                   <a:srgbClr val="0F2043"/>
                 </a:solidFill>
@@ -24875,23 +24971,23 @@
               <a:t>⑧ No class weighting</a:t>
             </a:r>
             <a:r>
-              <a:rPr sz="1050" b="0">
+              <a:rPr sz="1000" b="0">
                 <a:solidFill>
                   <a:srgbClr val="1E1E1E"/>
                 </a:solidFill>
                 <a:latin typeface="Calibri"/>
               </a:rPr>
-              <a:t> (training)</a:t>
+              <a:t> — tf_unet has none either; our earlier version used it and scored lower</a:t>
             </a:r>
           </a:p>
           <a:p>
             <a:pPr algn="l">
               <a:spcAft>
-                <a:spcPts val="300"/>
+                <a:spcPts val="200"/>
               </a:spcAft>
             </a:pPr>
             <a:r>
-              <a:rPr sz="1050" b="1">
+              <a:rPr sz="1000" b="1">
                 <a:solidFill>
                   <a:srgbClr val="0F2043"/>
                 </a:solidFill>
@@ -24900,29 +24996,29 @@
               <a:t>⑨ Size</a:t>
             </a:r>
             <a:r>
-              <a:rPr sz="1050" b="0">
+              <a:rPr sz="1000" b="0">
                 <a:solidFill>
                   <a:srgbClr val="1E1E1E"/>
                 </a:solidFill>
                 <a:latin typeface="Calibri"/>
               </a:rPr>
-              <a:t>: 8 → 16 → 32 → 64 → 128 channels, 593,842 parameters</a:t>
+              <a:t>: shrinks 4 times, 8 → 128 channels, 593,842 parameters</a:t>
             </a:r>
           </a:p>
           <a:p>
             <a:pPr algn="l">
               <a:spcAft>
-                <a:spcPts val="300"/>
+                <a:spcPts val="200"/>
               </a:spcAft>
             </a:pPr>
             <a:r>
-              <a:rPr sz="1050" b="1">
+              <a:rPr sz="1000" b="1">
                 <a:solidFill>
                   <a:srgbClr val="E31837"/>
                 </a:solidFill>
                 <a:latin typeface="Calibri"/>
               </a:rPr>
-              <a:t>Red = RFI-specific additions ①–③</a:t>
+              <a:t>Red = the three added modules ①–③</a:t>
             </a:r>
           </a:p>
         </p:txBody>
@@ -25070,7 +25166,7 @@
                 </a:solidFill>
                 <a:latin typeface="Calibri"/>
               </a:rPr>
-              <a:t>Two 3×3 convolutions, each tidied by GroupNorm; the input is added back at the end.</a:t>
+              <a:t>Two 3×3 convolutions, each tidied by GroupNorm; the input is added back at the end. Dropout works in training only.</a:t>
             </a:r>
           </a:p>
         </p:txBody>
@@ -25289,10 +25385,10 @@
         </p:nvGrpSpPr>
         <p:grpSpPr>
           <a:xfrm>
-            <a:off x="2697480" y="1728216"/>
-            <a:ext cx="8074152" cy="996696"/>
-            <a:chOff x="2697480" y="1728216"/>
-            <a:chExt cx="8074152" cy="996696"/>
+            <a:off x="2697480" y="1764792"/>
+            <a:ext cx="8741664" cy="1033272"/>
+            <a:chOff x="2697480" y="1764792"/>
+            <a:chExt cx="8741664" cy="1033272"/>
           </a:xfrm>
         </p:grpSpPr>
         <p:sp>
@@ -25303,8 +25399,8 @@
           </p:nvSpPr>
           <p:spPr>
             <a:xfrm>
-              <a:off x="2697480" y="2267712"/>
-              <a:ext cx="566928" cy="457200"/>
+              <a:off x="2697480" y="2340864"/>
+              <a:ext cx="530352" cy="457200"/>
             </a:xfrm>
             <a:prstGeom prst="roundRect">
               <a:avLst/>
@@ -25337,7 +25433,7 @@
             <a:p>
               <a:pPr algn="ctr"/>
               <a:r>
-                <a:rPr sz="1050" b="1">
+                <a:rPr sz="1000" b="1">
                   <a:solidFill>
                     <a:srgbClr val="1E1E1E"/>
                   </a:solidFill>
@@ -25356,8 +25452,8 @@
           </p:nvCxnSpPr>
           <p:spPr>
             <a:xfrm>
-              <a:off x="3264408" y="2496312"/>
-              <a:ext cx="164592" cy="0"/>
+              <a:off x="3227832" y="2569464"/>
+              <a:ext cx="137160" cy="0"/>
             </a:xfrm>
             <a:prstGeom prst="line">
               <a:avLst/>
@@ -25392,8 +25488,8 @@
           </p:nvSpPr>
           <p:spPr>
             <a:xfrm>
-              <a:off x="3429000" y="2267712"/>
-              <a:ext cx="841248" cy="457200"/>
+              <a:off x="3364992" y="2340864"/>
+              <a:ext cx="749808" cy="457200"/>
             </a:xfrm>
             <a:prstGeom prst="roundRect">
               <a:avLst/>
@@ -25426,7 +25522,7 @@
             <a:p>
               <a:pPr algn="ctr"/>
               <a:r>
-                <a:rPr sz="1050" b="1">
+                <a:rPr sz="1000" b="1">
                   <a:solidFill>
                     <a:srgbClr val="FFFFFF"/>
                   </a:solidFill>
@@ -25445,8 +25541,8 @@
           </p:nvCxnSpPr>
           <p:spPr>
             <a:xfrm>
-              <a:off x="4270248" y="2496312"/>
-              <a:ext cx="164592" cy="0"/>
+              <a:off x="4114800" y="2569464"/>
+              <a:ext cx="137160" cy="0"/>
             </a:xfrm>
             <a:prstGeom prst="line">
               <a:avLst/>
@@ -25481,8 +25577,8 @@
           </p:nvSpPr>
           <p:spPr>
             <a:xfrm>
-              <a:off x="4434840" y="2267712"/>
-              <a:ext cx="1097280" cy="457200"/>
+              <a:off x="4251960" y="2340864"/>
+              <a:ext cx="1051560" cy="457200"/>
             </a:xfrm>
             <a:prstGeom prst="roundRect">
               <a:avLst/>
@@ -25515,7 +25611,7 @@
             <a:p>
               <a:pPr algn="ctr"/>
               <a:r>
-                <a:rPr sz="1050" b="1">
+                <a:rPr sz="1000" b="1">
                   <a:solidFill>
                     <a:srgbClr val="FFFFFF"/>
                   </a:solidFill>
@@ -25534,8 +25630,8 @@
           </p:nvCxnSpPr>
           <p:spPr>
             <a:xfrm>
-              <a:off x="5532120" y="2496312"/>
-              <a:ext cx="164592" cy="0"/>
+              <a:off x="5303520" y="2569464"/>
+              <a:ext cx="137160" cy="0"/>
             </a:xfrm>
             <a:prstGeom prst="line">
               <a:avLst/>
@@ -25570,8 +25666,8 @@
           </p:nvSpPr>
           <p:spPr>
             <a:xfrm>
-              <a:off x="5696712" y="2267712"/>
-              <a:ext cx="640080" cy="457200"/>
+              <a:off x="5440680" y="2340864"/>
+              <a:ext cx="548640" cy="457200"/>
             </a:xfrm>
             <a:prstGeom prst="roundRect">
               <a:avLst/>
@@ -25604,7 +25700,7 @@
             <a:p>
               <a:pPr algn="ctr"/>
               <a:r>
-                <a:rPr sz="1050" b="1">
+                <a:rPr sz="1000" b="1">
                   <a:solidFill>
                     <a:srgbClr val="FFFFFF"/>
                   </a:solidFill>
@@ -25623,8 +25719,8 @@
           </p:nvCxnSpPr>
           <p:spPr>
             <a:xfrm>
-              <a:off x="6336792" y="2496312"/>
-              <a:ext cx="164592" cy="0"/>
+              <a:off x="5989320" y="2569464"/>
+              <a:ext cx="137160" cy="0"/>
             </a:xfrm>
             <a:prstGeom prst="line">
               <a:avLst/>
@@ -25659,8 +25755,97 @@
           </p:nvSpPr>
           <p:spPr>
             <a:xfrm>
-              <a:off x="6501384" y="2267712"/>
-              <a:ext cx="841248" cy="457200"/>
+              <a:off x="6126480" y="2340864"/>
+              <a:ext cx="731520" cy="457200"/>
+            </a:xfrm>
+            <a:prstGeom prst="roundRect">
+              <a:avLst/>
+            </a:prstGeom>
+            <a:solidFill>
+              <a:srgbClr val="5A6170"/>
+            </a:solidFill>
+            <a:ln>
+              <a:noFill/>
+            </a:ln>
+            <a:effectLst/>
+          </p:spPr>
+          <p:style>
+            <a:lnRef idx="1">
+              <a:schemeClr val="accent1"/>
+            </a:lnRef>
+            <a:fillRef idx="3">
+              <a:schemeClr val="accent1"/>
+            </a:fillRef>
+            <a:effectRef idx="2">
+              <a:schemeClr val="accent1"/>
+            </a:effectRef>
+            <a:fontRef idx="minor">
+              <a:schemeClr val="lt1"/>
+            </a:fontRef>
+          </p:style>
+          <p:txBody>
+            <a:bodyPr rtlCol="0" anchor="ctr" wrap="square" lIns="36576" rIns="36576" tIns="9144" bIns="9144"/>
+            <a:lstStyle/>
+            <a:p>
+              <a:pPr algn="ctr"/>
+              <a:r>
+                <a:rPr sz="1000" b="1">
+                  <a:solidFill>
+                    <a:srgbClr val="FFFFFF"/>
+                  </a:solidFill>
+                  <a:latin typeface="Calibri"/>
+                </a:rPr>
+                <a:t>Dropout</a:t>
+              </a:r>
+            </a:p>
+          </p:txBody>
+        </p:sp>
+        <p:cxnSp>
+          <p:nvCxnSpPr>
+            <p:cNvPr id="19" name="Connector 18"/>
+            <p:cNvCxnSpPr/>
+            <p:nvPr/>
+          </p:nvCxnSpPr>
+          <p:spPr>
+            <a:xfrm>
+              <a:off x="6858000" y="2569464"/>
+              <a:ext cx="137160" cy="0"/>
+            </a:xfrm>
+            <a:prstGeom prst="line">
+              <a:avLst/>
+            </a:prstGeom>
+            <a:ln w="19050">
+              <a:solidFill>
+                <a:srgbClr val="1E1E1E"/>
+              </a:solidFill>
+              <a:tailEnd type="triangle" w="med" len="med"/>
+            </a:ln>
+          </p:spPr>
+          <p:style>
+            <a:lnRef idx="2">
+              <a:schemeClr val="accent1"/>
+            </a:lnRef>
+            <a:fillRef idx="0">
+              <a:schemeClr val="accent1"/>
+            </a:fillRef>
+            <a:effectRef idx="1">
+              <a:schemeClr val="accent1"/>
+            </a:effectRef>
+            <a:fontRef idx="minor">
+              <a:schemeClr val="tx1"/>
+            </a:fontRef>
+          </p:style>
+        </p:cxnSp>
+        <p:sp>
+          <p:nvSpPr>
+            <p:cNvPr id="20" name="Rounded Rectangle 19"/>
+            <p:cNvSpPr/>
+            <p:nvPr/>
+          </p:nvSpPr>
+          <p:spPr>
+            <a:xfrm>
+              <a:off x="6995160" y="2340864"/>
+              <a:ext cx="749808" cy="457200"/>
             </a:xfrm>
             <a:prstGeom prst="roundRect">
               <a:avLst/>
@@ -25693,7 +25878,7 @@
             <a:p>
               <a:pPr algn="ctr"/>
               <a:r>
-                <a:rPr sz="1050" b="1">
+                <a:rPr sz="1000" b="1">
                   <a:solidFill>
                     <a:srgbClr val="FFFFFF"/>
                   </a:solidFill>
@@ -25706,14 +25891,14 @@
         </p:sp>
         <p:cxnSp>
           <p:nvCxnSpPr>
-            <p:cNvPr id="19" name="Connector 18"/>
+            <p:cNvPr id="21" name="Connector 20"/>
             <p:cNvCxnSpPr/>
             <p:nvPr/>
           </p:nvCxnSpPr>
           <p:spPr>
             <a:xfrm>
-              <a:off x="7342632" y="2496312"/>
-              <a:ext cx="164592" cy="0"/>
+              <a:off x="7744968" y="2569464"/>
+              <a:ext cx="137160" cy="0"/>
             </a:xfrm>
             <a:prstGeom prst="line">
               <a:avLst/>
@@ -25742,14 +25927,14 @@
         </p:cxnSp>
         <p:sp>
           <p:nvSpPr>
-            <p:cNvPr id="20" name="Rounded Rectangle 19"/>
+            <p:cNvPr id="22" name="Rounded Rectangle 21"/>
             <p:cNvSpPr/>
             <p:nvPr/>
           </p:nvSpPr>
           <p:spPr>
             <a:xfrm>
-              <a:off x="7507224" y="2267712"/>
-              <a:ext cx="1097280" cy="457200"/>
+              <a:off x="7882128" y="2340864"/>
+              <a:ext cx="1051560" cy="457200"/>
             </a:xfrm>
             <a:prstGeom prst="roundRect">
               <a:avLst/>
@@ -25782,7 +25967,7 @@
             <a:p>
               <a:pPr algn="ctr"/>
               <a:r>
-                <a:rPr sz="1050" b="1">
+                <a:rPr sz="1000" b="1">
                   <a:solidFill>
                     <a:srgbClr val="FFFFFF"/>
                   </a:solidFill>
@@ -25795,14 +25980,14 @@
         </p:sp>
         <p:cxnSp>
           <p:nvCxnSpPr>
-            <p:cNvPr id="21" name="Connector 20"/>
+            <p:cNvPr id="23" name="Connector 22"/>
             <p:cNvCxnSpPr/>
             <p:nvPr/>
           </p:nvCxnSpPr>
           <p:spPr>
             <a:xfrm>
-              <a:off x="8604504" y="2496312"/>
-              <a:ext cx="164592" cy="0"/>
+              <a:off x="8933688" y="2569464"/>
+              <a:ext cx="137160" cy="0"/>
             </a:xfrm>
             <a:prstGeom prst="line">
               <a:avLst/>
@@ -25831,14 +26016,14 @@
         </p:cxnSp>
         <p:sp>
           <p:nvSpPr>
-            <p:cNvPr id="22" name="Oval 21"/>
+            <p:cNvPr id="24" name="Oval 23"/>
             <p:cNvSpPr/>
             <p:nvPr/>
           </p:nvSpPr>
           <p:spPr>
             <a:xfrm>
-              <a:off x="8769096" y="2322576"/>
-              <a:ext cx="347472" cy="347472"/>
+              <a:off x="9070848" y="2404872"/>
+              <a:ext cx="329184" cy="329184"/>
             </a:xfrm>
             <a:prstGeom prst="ellipse">
               <a:avLst/>
@@ -25884,14 +26069,14 @@
         </p:sp>
         <p:cxnSp>
           <p:nvCxnSpPr>
-            <p:cNvPr id="23" name="Connector 22"/>
+            <p:cNvPr id="25" name="Connector 24"/>
             <p:cNvCxnSpPr/>
             <p:nvPr/>
           </p:nvCxnSpPr>
           <p:spPr>
             <a:xfrm>
-              <a:off x="9116568" y="2496312"/>
-              <a:ext cx="164592" cy="0"/>
+              <a:off x="9400032" y="2569464"/>
+              <a:ext cx="137160" cy="0"/>
             </a:xfrm>
             <a:prstGeom prst="line">
               <a:avLst/>
@@ -25920,14 +26105,14 @@
         </p:cxnSp>
         <p:sp>
           <p:nvSpPr>
-            <p:cNvPr id="24" name="Rounded Rectangle 23"/>
+            <p:cNvPr id="26" name="Rounded Rectangle 25"/>
             <p:cNvSpPr/>
             <p:nvPr/>
           </p:nvSpPr>
           <p:spPr>
             <a:xfrm>
-              <a:off x="9281160" y="2267712"/>
-              <a:ext cx="640080" cy="457200"/>
+              <a:off x="9537192" y="2340864"/>
+              <a:ext cx="548640" cy="457200"/>
             </a:xfrm>
             <a:prstGeom prst="roundRect">
               <a:avLst/>
@@ -25960,7 +26145,7 @@
             <a:p>
               <a:pPr algn="ctr"/>
               <a:r>
-                <a:rPr sz="1050" b="1">
+                <a:rPr sz="1000" b="1">
                   <a:solidFill>
                     <a:srgbClr val="FFFFFF"/>
                   </a:solidFill>
@@ -25973,14 +26158,14 @@
         </p:sp>
         <p:cxnSp>
           <p:nvCxnSpPr>
-            <p:cNvPr id="25" name="Connector 24"/>
+            <p:cNvPr id="27" name="Connector 26"/>
             <p:cNvCxnSpPr/>
             <p:nvPr/>
           </p:nvCxnSpPr>
           <p:spPr>
             <a:xfrm>
-              <a:off x="9921240" y="2496312"/>
-              <a:ext cx="164592" cy="0"/>
+              <a:off x="10085832" y="2569464"/>
+              <a:ext cx="137160" cy="0"/>
             </a:xfrm>
             <a:prstGeom prst="line">
               <a:avLst/>
@@ -26009,14 +26194,14 @@
         </p:cxnSp>
         <p:sp>
           <p:nvSpPr>
-            <p:cNvPr id="26" name="Rounded Rectangle 25"/>
+            <p:cNvPr id="28" name="Rounded Rectangle 27"/>
             <p:cNvSpPr/>
             <p:nvPr/>
           </p:nvSpPr>
           <p:spPr>
             <a:xfrm>
-              <a:off x="10085832" y="2267712"/>
-              <a:ext cx="685800" cy="457200"/>
+              <a:off x="10222992" y="2340864"/>
+              <a:ext cx="621792" cy="457200"/>
             </a:xfrm>
             <a:prstGeom prst="roundRect">
               <a:avLst/>
@@ -26049,7 +26234,7 @@
             <a:p>
               <a:pPr algn="ctr"/>
               <a:r>
-                <a:rPr sz="1050" b="1">
+                <a:rPr sz="1000" b="1">
                   <a:solidFill>
                     <a:srgbClr val="1E1E1E"/>
                   </a:solidFill>
@@ -26062,14 +26247,14 @@
         </p:sp>
         <p:cxnSp>
           <p:nvCxnSpPr>
-            <p:cNvPr id="27" name="Connector 26"/>
+            <p:cNvPr id="29" name="Connector 28"/>
             <p:cNvCxnSpPr/>
             <p:nvPr/>
           </p:nvCxnSpPr>
           <p:spPr>
             <a:xfrm flipV="1">
-              <a:off x="2980944" y="1975104"/>
-              <a:ext cx="0" cy="292608"/>
+              <a:off x="2962656" y="2011680"/>
+              <a:ext cx="0" cy="329184"/>
             </a:xfrm>
             <a:prstGeom prst="line">
               <a:avLst/>
@@ -26097,14 +26282,14 @@
         </p:cxnSp>
         <p:cxnSp>
           <p:nvCxnSpPr>
-            <p:cNvPr id="28" name="Connector 27"/>
+            <p:cNvPr id="30" name="Connector 29"/>
             <p:cNvCxnSpPr/>
             <p:nvPr/>
           </p:nvCxnSpPr>
           <p:spPr>
             <a:xfrm>
-              <a:off x="2980944" y="1975104"/>
-              <a:ext cx="5961888" cy="0"/>
+              <a:off x="2962656" y="2011680"/>
+              <a:ext cx="502920" cy="0"/>
             </a:xfrm>
             <a:prstGeom prst="line">
               <a:avLst/>
@@ -26130,16 +26315,106 @@
             </a:fontRef>
           </p:style>
         </p:cxnSp>
+        <p:sp>
+          <p:nvSpPr>
+            <p:cNvPr id="31" name="Rounded Rectangle 30"/>
+            <p:cNvSpPr/>
+            <p:nvPr/>
+          </p:nvSpPr>
+          <p:spPr>
+            <a:xfrm>
+              <a:off x="3465576" y="1883664"/>
+              <a:ext cx="731520" cy="256032"/>
+            </a:xfrm>
+            <a:prstGeom prst="roundRect">
+              <a:avLst/>
+            </a:prstGeom>
+            <a:solidFill>
+              <a:srgbClr val="FFFFFF"/>
+            </a:solidFill>
+            <a:ln w="12700">
+              <a:solidFill>
+                <a:srgbClr val="E31837"/>
+              </a:solidFill>
+            </a:ln>
+            <a:effectLst/>
+          </p:spPr>
+          <p:style>
+            <a:lnRef idx="1">
+              <a:schemeClr val="accent1"/>
+            </a:lnRef>
+            <a:fillRef idx="3">
+              <a:schemeClr val="accent1"/>
+            </a:fillRef>
+            <a:effectRef idx="2">
+              <a:schemeClr val="accent1"/>
+            </a:effectRef>
+            <a:fontRef idx="minor">
+              <a:schemeClr val="lt1"/>
+            </a:fontRef>
+          </p:style>
+          <p:txBody>
+            <a:bodyPr rtlCol="0" anchor="ctr" wrap="square" lIns="36576" rIns="36576" tIns="9144" bIns="9144"/>
+            <a:lstStyle/>
+            <a:p>
+              <a:pPr algn="ctr"/>
+              <a:r>
+                <a:rPr sz="950" b="1">
+                  <a:solidFill>
+                    <a:srgbClr val="E31837"/>
+                  </a:solidFill>
+                  <a:latin typeface="Calibri"/>
+                </a:rPr>
+                <a:t>1×1 conv</a:t>
+              </a:r>
+            </a:p>
+          </p:txBody>
+        </p:sp>
         <p:cxnSp>
           <p:nvCxnSpPr>
-            <p:cNvPr id="29" name="Connector 28"/>
+            <p:cNvPr id="32" name="Connector 31"/>
             <p:cNvCxnSpPr/>
             <p:nvPr/>
           </p:nvCxnSpPr>
           <p:spPr>
             <a:xfrm>
-              <a:off x="8942832" y="1975104"/>
-              <a:ext cx="0" cy="347472"/>
+              <a:off x="4197096" y="2011680"/>
+              <a:ext cx="5038344" cy="0"/>
+            </a:xfrm>
+            <a:prstGeom prst="line">
+              <a:avLst/>
+            </a:prstGeom>
+            <a:ln w="25400">
+              <a:solidFill>
+                <a:srgbClr val="E31837"/>
+              </a:solidFill>
+            </a:ln>
+          </p:spPr>
+          <p:style>
+            <a:lnRef idx="2">
+              <a:schemeClr val="accent1"/>
+            </a:lnRef>
+            <a:fillRef idx="0">
+              <a:schemeClr val="accent1"/>
+            </a:fillRef>
+            <a:effectRef idx="1">
+              <a:schemeClr val="accent1"/>
+            </a:effectRef>
+            <a:fontRef idx="minor">
+              <a:schemeClr val="tx1"/>
+            </a:fontRef>
+          </p:style>
+        </p:cxnSp>
+        <p:cxnSp>
+          <p:nvCxnSpPr>
+            <p:cNvPr id="33" name="Connector 32"/>
+            <p:cNvCxnSpPr/>
+            <p:nvPr/>
+          </p:nvCxnSpPr>
+          <p:spPr>
+            <a:xfrm>
+              <a:off x="9235440" y="2011680"/>
+              <a:ext cx="0" cy="393192"/>
             </a:xfrm>
             <a:prstGeom prst="line">
               <a:avLst/>
@@ -26168,14 +26443,14 @@
         </p:cxnSp>
         <p:sp>
           <p:nvSpPr>
-            <p:cNvPr id="30" name="TextBox 29"/>
+            <p:cNvPr id="34" name="TextBox 33"/>
             <p:cNvSpPr txBox="1"/>
             <p:nvPr/>
           </p:nvSpPr>
           <p:spPr>
             <a:xfrm>
-              <a:off x="3072384" y="1728216"/>
-              <a:ext cx="7315200" cy="228600"/>
+              <a:off x="4306824" y="1764792"/>
+              <a:ext cx="7132320" cy="201168"/>
             </a:xfrm>
             <a:prstGeom prst="rect">
               <a:avLst/>
@@ -26194,7 +26469,7 @@
                 </a:spcAft>
               </a:pPr>
               <a:r>
-                <a:rPr sz="950" b="1">
+                <a:rPr sz="900" b="1">
                   <a:solidFill>
                     <a:srgbClr val="E31837"/>
                   </a:solidFill>
@@ -26203,13 +26478,13 @@
                 <a:t>② shortcut: </a:t>
               </a:r>
               <a:r>
-                <a:rPr sz="950" b="0">
+                <a:rPr sz="900" b="0">
                   <a:solidFill>
                     <a:srgbClr val="E31837"/>
                   </a:solidFill>
                   <a:latin typeface="Calibri"/>
                 </a:rPr>
-                <a:t>the input skips the block and is added back (1×1 conv if channel count changes)</a:t>
+                <a:t>input goes around the block and is added back (via a 1×1 conv: every ResBlock here changes the channel count)</a:t>
               </a:r>
             </a:p>
           </p:txBody>
@@ -26217,21 +26492,21 @@
       </p:grpSp>
       <p:grpSp>
         <p:nvGrpSpPr>
-          <p:cNvPr id="31" name="Group 30"/>
+          <p:cNvPr id="35" name="Group 34"/>
           <p:cNvGrpSpPr/>
           <p:nvPr/>
         </p:nvGrpSpPr>
         <p:grpSpPr>
           <a:xfrm>
             <a:off x="2697480" y="3218688"/>
-            <a:ext cx="8110727" cy="1600200"/>
+            <a:ext cx="8001000" cy="1600200"/>
             <a:chOff x="2697480" y="3218688"/>
-            <a:chExt cx="8110727" cy="1600200"/>
+            <a:chExt cx="8001000" cy="1600200"/>
           </a:xfrm>
         </p:grpSpPr>
         <p:sp>
           <p:nvSpPr>
-            <p:cNvPr id="32" name="Rounded Rectangle 31"/>
+            <p:cNvPr id="36" name="Rounded Rectangle 35"/>
             <p:cNvSpPr/>
             <p:nvPr/>
           </p:nvSpPr>
@@ -26284,7 +26559,7 @@
         </p:sp>
         <p:sp>
           <p:nvSpPr>
-            <p:cNvPr id="33" name="Rounded Rectangle 32"/>
+            <p:cNvPr id="37" name="Rounded Rectangle 36"/>
             <p:cNvSpPr/>
             <p:nvPr/>
           </p:nvSpPr>
@@ -26337,7 +26612,7 @@
         </p:sp>
         <p:cxnSp>
           <p:nvCxnSpPr>
-            <p:cNvPr id="34" name="Connector 33"/>
+            <p:cNvPr id="38" name="Connector 37"/>
             <p:cNvCxnSpPr/>
             <p:nvPr/>
           </p:nvCxnSpPr>
@@ -26373,7 +26648,7 @@
         </p:cxnSp>
         <p:sp>
           <p:nvSpPr>
-            <p:cNvPr id="35" name="Rounded Rectangle 34"/>
+            <p:cNvPr id="39" name="Rounded Rectangle 38"/>
             <p:cNvSpPr/>
             <p:nvPr/>
           </p:nvSpPr>
@@ -26426,7 +26701,7 @@
         </p:sp>
         <p:cxnSp>
           <p:nvCxnSpPr>
-            <p:cNvPr id="36" name="Connector 35"/>
+            <p:cNvPr id="40" name="Connector 39"/>
             <p:cNvCxnSpPr/>
             <p:nvPr/>
           </p:nvCxnSpPr>
@@ -26462,7 +26737,7 @@
         </p:cxnSp>
         <p:sp>
           <p:nvSpPr>
-            <p:cNvPr id="37" name="Rounded Rectangle 36"/>
+            <p:cNvPr id="41" name="Rounded Rectangle 40"/>
             <p:cNvSpPr/>
             <p:nvPr/>
           </p:nvSpPr>
@@ -26515,7 +26790,7 @@
         </p:sp>
         <p:cxnSp>
           <p:nvCxnSpPr>
-            <p:cNvPr id="38" name="Connector 37"/>
+            <p:cNvPr id="42" name="Connector 41"/>
             <p:cNvCxnSpPr/>
             <p:nvPr/>
           </p:nvCxnSpPr>
@@ -26551,7 +26826,7 @@
         </p:cxnSp>
         <p:sp>
           <p:nvSpPr>
-            <p:cNvPr id="39" name="Rounded Rectangle 38"/>
+            <p:cNvPr id="43" name="Rounded Rectangle 42"/>
             <p:cNvSpPr/>
             <p:nvPr/>
           </p:nvSpPr>
@@ -26604,7 +26879,7 @@
         </p:sp>
         <p:cxnSp>
           <p:nvCxnSpPr>
-            <p:cNvPr id="40" name="Connector 39"/>
+            <p:cNvPr id="44" name="Connector 43"/>
             <p:cNvCxnSpPr/>
             <p:nvPr/>
           </p:nvCxnSpPr>
@@ -26640,7 +26915,7 @@
         </p:cxnSp>
         <p:sp>
           <p:nvSpPr>
-            <p:cNvPr id="41" name="Rounded Rectangle 40"/>
+            <p:cNvPr id="45" name="Rounded Rectangle 44"/>
             <p:cNvSpPr/>
             <p:nvPr/>
           </p:nvSpPr>
@@ -26705,7 +26980,7 @@
         </p:sp>
         <p:cxnSp>
           <p:nvCxnSpPr>
-            <p:cNvPr id="42" name="Connector 41"/>
+            <p:cNvPr id="46" name="Connector 45"/>
             <p:cNvCxnSpPr/>
             <p:nvPr/>
           </p:nvCxnSpPr>
@@ -26741,7 +27016,7 @@
         </p:cxnSp>
         <p:cxnSp>
           <p:nvCxnSpPr>
-            <p:cNvPr id="43" name="Connector 42"/>
+            <p:cNvPr id="47" name="Connector 46"/>
             <p:cNvCxnSpPr/>
             <p:nvPr/>
           </p:nvCxnSpPr>
@@ -26777,7 +27052,7 @@
         </p:cxnSp>
         <p:cxnSp>
           <p:nvCxnSpPr>
-            <p:cNvPr id="44" name="Connector 43"/>
+            <p:cNvPr id="48" name="Connector 47"/>
             <p:cNvCxnSpPr/>
             <p:nvPr/>
           </p:nvCxnSpPr>
@@ -26813,7 +27088,7 @@
         </p:cxnSp>
         <p:cxnSp>
           <p:nvCxnSpPr>
-            <p:cNvPr id="45" name="Connector 44"/>
+            <p:cNvPr id="49" name="Connector 48"/>
             <p:cNvCxnSpPr/>
             <p:nvPr/>
           </p:nvCxnSpPr>
@@ -26849,14 +27124,14 @@
         </p:cxnSp>
         <p:cxnSp>
           <p:nvCxnSpPr>
-            <p:cNvPr id="46" name="Connector 45"/>
+            <p:cNvPr id="50" name="Connector 49"/>
             <p:cNvCxnSpPr/>
             <p:nvPr/>
           </p:nvCxnSpPr>
           <p:spPr>
             <a:xfrm>
               <a:off x="6675120" y="4000500"/>
-              <a:ext cx="164592" cy="0"/>
+              <a:ext cx="137160" cy="0"/>
             </a:xfrm>
             <a:prstGeom prst="line">
               <a:avLst/>
@@ -26885,13 +27160,13 @@
         </p:cxnSp>
         <p:sp>
           <p:nvSpPr>
-            <p:cNvPr id="47" name="Rounded Rectangle 46"/>
+            <p:cNvPr id="51" name="Rounded Rectangle 50"/>
             <p:cNvSpPr/>
             <p:nvPr/>
           </p:nvSpPr>
           <p:spPr>
             <a:xfrm>
-              <a:off x="6839712" y="3771900"/>
+              <a:off x="6812280" y="3771900"/>
               <a:ext cx="1051560" cy="457200"/>
             </a:xfrm>
             <a:prstGeom prst="roundRect">
@@ -26938,14 +27213,14 @@
         </p:sp>
         <p:cxnSp>
           <p:nvCxnSpPr>
-            <p:cNvPr id="48" name="Connector 47"/>
+            <p:cNvPr id="52" name="Connector 51"/>
             <p:cNvCxnSpPr/>
             <p:nvPr/>
           </p:nvCxnSpPr>
           <p:spPr>
             <a:xfrm>
-              <a:off x="7891272" y="4000500"/>
-              <a:ext cx="164592" cy="0"/>
+              <a:off x="7863840" y="4000500"/>
+              <a:ext cx="137160" cy="0"/>
             </a:xfrm>
             <a:prstGeom prst="line">
               <a:avLst/>
@@ -26974,13 +27249,13 @@
         </p:cxnSp>
         <p:sp>
           <p:nvSpPr>
-            <p:cNvPr id="49" name="Rounded Rectangle 48"/>
+            <p:cNvPr id="53" name="Rounded Rectangle 52"/>
             <p:cNvSpPr/>
             <p:nvPr/>
           </p:nvSpPr>
           <p:spPr>
             <a:xfrm>
-              <a:off x="8055864" y="3771900"/>
+              <a:off x="8001000" y="3771900"/>
               <a:ext cx="1097280" cy="457200"/>
             </a:xfrm>
             <a:prstGeom prst="roundRect">
@@ -27027,14 +27302,14 @@
         </p:sp>
         <p:cxnSp>
           <p:nvCxnSpPr>
-            <p:cNvPr id="50" name="Connector 49"/>
+            <p:cNvPr id="54" name="Connector 53"/>
             <p:cNvCxnSpPr/>
             <p:nvPr/>
           </p:nvCxnSpPr>
           <p:spPr>
             <a:xfrm>
-              <a:off x="9153144" y="4000500"/>
-              <a:ext cx="164592" cy="0"/>
+              <a:off x="9098280" y="4000500"/>
+              <a:ext cx="137160" cy="0"/>
             </a:xfrm>
             <a:prstGeom prst="line">
               <a:avLst/>
@@ -27063,13 +27338,13 @@
         </p:cxnSp>
         <p:sp>
           <p:nvSpPr>
-            <p:cNvPr id="51" name="Rounded Rectangle 50"/>
+            <p:cNvPr id="55" name="Rounded Rectangle 54"/>
             <p:cNvSpPr/>
             <p:nvPr/>
           </p:nvSpPr>
           <p:spPr>
             <a:xfrm>
-              <a:off x="9317736" y="3771900"/>
+              <a:off x="9235440" y="3771900"/>
               <a:ext cx="640080" cy="457200"/>
             </a:xfrm>
             <a:prstGeom prst="roundRect">
@@ -27116,14 +27391,14 @@
         </p:sp>
         <p:cxnSp>
           <p:nvCxnSpPr>
-            <p:cNvPr id="52" name="Connector 51"/>
+            <p:cNvPr id="56" name="Connector 55"/>
             <p:cNvCxnSpPr/>
             <p:nvPr/>
           </p:nvCxnSpPr>
           <p:spPr>
             <a:xfrm>
-              <a:off x="9957815" y="4000500"/>
-              <a:ext cx="164592" cy="0"/>
+              <a:off x="9875520" y="4000500"/>
+              <a:ext cx="137160" cy="0"/>
             </a:xfrm>
             <a:prstGeom prst="line">
               <a:avLst/>
@@ -27152,13 +27427,13 @@
         </p:cxnSp>
         <p:sp>
           <p:nvSpPr>
-            <p:cNvPr id="53" name="Rounded Rectangle 52"/>
+            <p:cNvPr id="57" name="Rounded Rectangle 56"/>
             <p:cNvSpPr/>
             <p:nvPr/>
           </p:nvSpPr>
           <p:spPr>
             <a:xfrm>
-              <a:off x="10122407" y="3771900"/>
+              <a:off x="10012680" y="3771900"/>
               <a:ext cx="685800" cy="457200"/>
             </a:xfrm>
             <a:prstGeom prst="roundRect">
@@ -27205,7 +27480,7 @@
         </p:sp>
         <p:sp>
           <p:nvSpPr>
-            <p:cNvPr id="54" name="TextBox 53"/>
+            <p:cNvPr id="58" name="TextBox 57"/>
             <p:cNvSpPr txBox="1"/>
             <p:nvPr/>
           </p:nvSpPr>
@@ -27237,7 +27512,7 @@
                   </a:solidFill>
                   <a:latin typeface="Calibri"/>
                 </a:rPr>
-                <a:t>Each path = 1×K along frequency, then K×1 along time → together it covers a K×K square (measured)</a:t>
+                <a:t>Each path = 1×K along frequency, then K×1 along time, each channel on its own → together it covers a K×K square (measured)</a:t>
               </a:r>
             </a:p>
           </p:txBody>
@@ -27245,21 +27520,21 @@
       </p:grpSp>
       <p:grpSp>
         <p:nvGrpSpPr>
-          <p:cNvPr id="55" name="Group 54"/>
+          <p:cNvPr id="59" name="Group 58"/>
           <p:cNvGrpSpPr/>
           <p:nvPr/>
         </p:nvGrpSpPr>
         <p:grpSpPr>
           <a:xfrm>
             <a:off x="2697480" y="5358384"/>
-            <a:ext cx="6510528" cy="886968"/>
+            <a:ext cx="6373368" cy="886968"/>
             <a:chOff x="2697480" y="5358384"/>
-            <a:chExt cx="6510528" cy="886968"/>
+            <a:chExt cx="6373368" cy="886968"/>
           </a:xfrm>
         </p:grpSpPr>
         <p:sp>
           <p:nvSpPr>
-            <p:cNvPr id="56" name="Rounded Rectangle 55"/>
+            <p:cNvPr id="60" name="Rounded Rectangle 59"/>
             <p:cNvSpPr/>
             <p:nvPr/>
           </p:nvSpPr>
@@ -27312,14 +27587,14 @@
         </p:sp>
         <p:cxnSp>
           <p:nvCxnSpPr>
-            <p:cNvPr id="57" name="Connector 56"/>
+            <p:cNvPr id="61" name="Connector 60"/>
             <p:cNvCxnSpPr/>
             <p:nvPr/>
           </p:nvCxnSpPr>
           <p:spPr>
             <a:xfrm>
               <a:off x="3264408" y="5609844"/>
-              <a:ext cx="164592" cy="0"/>
+              <a:ext cx="137160" cy="0"/>
             </a:xfrm>
             <a:prstGeom prst="line">
               <a:avLst/>
@@ -27348,13 +27623,13 @@
         </p:cxnSp>
         <p:sp>
           <p:nvSpPr>
-            <p:cNvPr id="58" name="Rounded Rectangle 57"/>
+            <p:cNvPr id="62" name="Rounded Rectangle 61"/>
             <p:cNvSpPr/>
             <p:nvPr/>
           </p:nvSpPr>
           <p:spPr>
             <a:xfrm>
-              <a:off x="3429000" y="5358384"/>
+              <a:off x="3401568" y="5358384"/>
               <a:ext cx="1463040" cy="502920"/>
             </a:xfrm>
             <a:prstGeom prst="roundRect">
@@ -27401,14 +27676,14 @@
         </p:sp>
         <p:cxnSp>
           <p:nvCxnSpPr>
-            <p:cNvPr id="59" name="Connector 58"/>
+            <p:cNvPr id="63" name="Connector 62"/>
             <p:cNvCxnSpPr/>
             <p:nvPr/>
           </p:nvCxnSpPr>
           <p:spPr>
             <a:xfrm>
-              <a:off x="4892040" y="5609844"/>
-              <a:ext cx="164592" cy="0"/>
+              <a:off x="4864608" y="5609844"/>
+              <a:ext cx="137160" cy="0"/>
             </a:xfrm>
             <a:prstGeom prst="line">
               <a:avLst/>
@@ -27437,13 +27712,13 @@
         </p:cxnSp>
         <p:sp>
           <p:nvSpPr>
-            <p:cNvPr id="60" name="Rounded Rectangle 59"/>
+            <p:cNvPr id="64" name="Rounded Rectangle 63"/>
             <p:cNvSpPr/>
             <p:nvPr/>
           </p:nvSpPr>
           <p:spPr>
             <a:xfrm>
-              <a:off x="5056632" y="5358384"/>
+              <a:off x="5001768" y="5358384"/>
               <a:ext cx="1417320" cy="502920"/>
             </a:xfrm>
             <a:prstGeom prst="roundRect">
@@ -27483,21 +27758,21 @@
                   </a:solidFill>
                   <a:latin typeface="Calibri"/>
                 </a:rPr>
-                <a:t>1-D conv (k = 3) across neighbours</a:t>
+                <a:t>1-D conv (k = 3) across neighbouring channels</a:t>
               </a:r>
             </a:p>
           </p:txBody>
         </p:sp>
         <p:cxnSp>
           <p:nvCxnSpPr>
-            <p:cNvPr id="61" name="Connector 60"/>
+            <p:cNvPr id="65" name="Connector 64"/>
             <p:cNvCxnSpPr/>
             <p:nvPr/>
           </p:nvCxnSpPr>
           <p:spPr>
             <a:xfrm>
-              <a:off x="6473952" y="5609844"/>
-              <a:ext cx="164592" cy="0"/>
+              <a:off x="6419088" y="5609844"/>
+              <a:ext cx="137160" cy="0"/>
             </a:xfrm>
             <a:prstGeom prst="line">
               <a:avLst/>
@@ -27526,13 +27801,13 @@
         </p:cxnSp>
         <p:sp>
           <p:nvSpPr>
-            <p:cNvPr id="62" name="Rounded Rectangle 61"/>
+            <p:cNvPr id="66" name="Rounded Rectangle 65"/>
             <p:cNvSpPr/>
             <p:nvPr/>
           </p:nvSpPr>
           <p:spPr>
             <a:xfrm>
-              <a:off x="6638544" y="5358384"/>
+              <a:off x="6556248" y="5358384"/>
               <a:ext cx="1188720" cy="502920"/>
             </a:xfrm>
             <a:prstGeom prst="roundRect">
@@ -27579,14 +27854,14 @@
         </p:sp>
         <p:cxnSp>
           <p:nvCxnSpPr>
-            <p:cNvPr id="63" name="Connector 62"/>
+            <p:cNvPr id="67" name="Connector 66"/>
             <p:cNvCxnSpPr/>
             <p:nvPr/>
           </p:nvCxnSpPr>
           <p:spPr>
             <a:xfrm>
-              <a:off x="7827264" y="5609844"/>
-              <a:ext cx="164592" cy="0"/>
+              <a:off x="7744968" y="5609844"/>
+              <a:ext cx="137160" cy="0"/>
             </a:xfrm>
             <a:prstGeom prst="line">
               <a:avLst/>
@@ -27615,13 +27890,13 @@
         </p:cxnSp>
         <p:sp>
           <p:nvSpPr>
-            <p:cNvPr id="64" name="Oval 63"/>
+            <p:cNvPr id="68" name="Oval 67"/>
             <p:cNvSpPr/>
             <p:nvPr/>
           </p:nvSpPr>
           <p:spPr>
             <a:xfrm>
-              <a:off x="7991856" y="5431536"/>
+              <a:off x="7882128" y="5431536"/>
               <a:ext cx="365760" cy="365760"/>
             </a:xfrm>
             <a:prstGeom prst="ellipse">
@@ -27668,14 +27943,14 @@
         </p:sp>
         <p:cxnSp>
           <p:nvCxnSpPr>
-            <p:cNvPr id="65" name="Connector 64"/>
+            <p:cNvPr id="69" name="Connector 68"/>
             <p:cNvCxnSpPr/>
             <p:nvPr/>
           </p:nvCxnSpPr>
           <p:spPr>
             <a:xfrm>
-              <a:off x="8357616" y="5609844"/>
-              <a:ext cx="164592" cy="0"/>
+              <a:off x="8247888" y="5609844"/>
+              <a:ext cx="137160" cy="0"/>
             </a:xfrm>
             <a:prstGeom prst="line">
               <a:avLst/>
@@ -27704,13 +27979,13 @@
         </p:cxnSp>
         <p:sp>
           <p:nvSpPr>
-            <p:cNvPr id="66" name="Rounded Rectangle 65"/>
+            <p:cNvPr id="70" name="Rounded Rectangle 69"/>
             <p:cNvSpPr/>
             <p:nvPr/>
           </p:nvSpPr>
           <p:spPr>
             <a:xfrm>
-              <a:off x="8522208" y="5358384"/>
+              <a:off x="8385048" y="5358384"/>
               <a:ext cx="685800" cy="502920"/>
             </a:xfrm>
             <a:prstGeom prst="roundRect">
@@ -27757,7 +28032,7 @@
         </p:sp>
         <p:cxnSp>
           <p:nvCxnSpPr>
-            <p:cNvPr id="67" name="Connector 66"/>
+            <p:cNvPr id="71" name="Connector 70"/>
             <p:cNvCxnSpPr/>
             <p:nvPr/>
           </p:nvCxnSpPr>
@@ -27792,14 +28067,14 @@
         </p:cxnSp>
         <p:cxnSp>
           <p:nvCxnSpPr>
-            <p:cNvPr id="68" name="Connector 67"/>
+            <p:cNvPr id="72" name="Connector 71"/>
             <p:cNvCxnSpPr/>
             <p:nvPr/>
           </p:nvCxnSpPr>
           <p:spPr>
             <a:xfrm>
               <a:off x="2980944" y="6062472"/>
-              <a:ext cx="5193792" cy="0"/>
+              <a:ext cx="5084064" cy="0"/>
             </a:xfrm>
             <a:prstGeom prst="line">
               <a:avLst/>
@@ -27827,13 +28102,13 @@
         </p:cxnSp>
         <p:cxnSp>
           <p:nvCxnSpPr>
-            <p:cNvPr id="69" name="Connector 68"/>
+            <p:cNvPr id="73" name="Connector 72"/>
             <p:cNvCxnSpPr/>
             <p:nvPr/>
           </p:nvCxnSpPr>
           <p:spPr>
             <a:xfrm flipV="1">
-              <a:off x="8174736" y="5797296"/>
+              <a:off x="8065008" y="5797296"/>
               <a:ext cx="0" cy="265176"/>
             </a:xfrm>
             <a:prstGeom prst="line">
@@ -27863,7 +28138,7 @@
         </p:cxnSp>
         <p:sp>
           <p:nvSpPr>
-            <p:cNvPr id="70" name="TextBox 69"/>
+            <p:cNvPr id="74" name="TextBox 73"/>
             <p:cNvSpPr txBox="1"/>
             <p:nvPr/>
           </p:nvSpPr>
@@ -27954,8 +28229,8 @@
         </p:nvSpPr>
         <p:spPr>
           <a:xfrm>
-            <a:off x="685800" y="1645920"/>
-            <a:ext cx="10835640" cy="1417320"/>
+            <a:off x="685800" y="1609344"/>
+            <a:ext cx="10835640" cy="1170432"/>
           </a:xfrm>
           <a:prstGeom prst="roundRect">
             <a:avLst>
@@ -28002,8 +28277,8 @@
         </p:nvSpPr>
         <p:spPr>
           <a:xfrm>
-            <a:off x="804672" y="1719072"/>
-            <a:ext cx="1920240" cy="1280160"/>
+            <a:off x="804672" y="1664208"/>
+            <a:ext cx="1828800" cy="1060704"/>
           </a:xfrm>
           <a:prstGeom prst="rect">
             <a:avLst/>
@@ -28057,10 +28332,10 @@
         </p:nvGrpSpPr>
         <p:grpSpPr>
           <a:xfrm>
-            <a:off x="2697480" y="2103120"/>
-            <a:ext cx="8366760" cy="566928"/>
-            <a:chOff x="2697480" y="2103120"/>
-            <a:chExt cx="8366760" cy="566928"/>
+            <a:off x="2697480" y="1920240"/>
+            <a:ext cx="8595359" cy="548640"/>
+            <a:chOff x="2697480" y="1920240"/>
+            <a:chExt cx="8595359" cy="548640"/>
           </a:xfrm>
         </p:grpSpPr>
         <p:sp>
@@ -28071,8 +28346,8 @@
           </p:nvSpPr>
           <p:spPr>
             <a:xfrm>
-              <a:off x="2697480" y="2103120"/>
-              <a:ext cx="1188720" cy="566928"/>
+              <a:off x="2697480" y="1920240"/>
+              <a:ext cx="1051560" cy="548640"/>
             </a:xfrm>
             <a:prstGeom prst="roundRect">
               <a:avLst/>
@@ -28105,7 +28380,7 @@
             <a:p>
               <a:pPr algn="ctr"/>
               <a:r>
-                <a:rPr sz="1050" b="0">
+                <a:rPr sz="1000" b="0">
                   <a:solidFill>
                     <a:srgbClr val="1E1E1E"/>
                   </a:solidFill>
@@ -28124,8 +28399,8 @@
           </p:nvCxnSpPr>
           <p:spPr>
             <a:xfrm>
-              <a:off x="3886200" y="2386584"/>
-              <a:ext cx="228600" cy="0"/>
+              <a:off x="3749039" y="2194560"/>
+              <a:ext cx="182881" cy="0"/>
             </a:xfrm>
             <a:prstGeom prst="line">
               <a:avLst/>
@@ -28160,8 +28435,97 @@
           </p:nvSpPr>
           <p:spPr>
             <a:xfrm>
-              <a:off x="4114800" y="2103120"/>
-              <a:ext cx="1143000" cy="566928"/>
+              <a:off x="3931920" y="1920240"/>
+              <a:ext cx="1188720" cy="548640"/>
+            </a:xfrm>
+            <a:prstGeom prst="roundRect">
+              <a:avLst/>
+            </a:prstGeom>
+            <a:solidFill>
+              <a:srgbClr val="2E4A7D"/>
+            </a:solidFill>
+            <a:ln>
+              <a:noFill/>
+            </a:ln>
+            <a:effectLst/>
+          </p:spPr>
+          <p:style>
+            <a:lnRef idx="1">
+              <a:schemeClr val="accent1"/>
+            </a:lnRef>
+            <a:fillRef idx="3">
+              <a:schemeClr val="accent1"/>
+            </a:fillRef>
+            <a:effectRef idx="2">
+              <a:schemeClr val="accent1"/>
+            </a:effectRef>
+            <a:fontRef idx="minor">
+              <a:schemeClr val="lt1"/>
+            </a:fontRef>
+          </p:style>
+          <p:txBody>
+            <a:bodyPr rtlCol="0" anchor="ctr" wrap="square" lIns="36576" rIns="36576" tIns="9144" bIns="9144"/>
+            <a:lstStyle/>
+            <a:p>
+              <a:pPr algn="ctr"/>
+              <a:r>
+                <a:rPr sz="1000" b="0">
+                  <a:solidFill>
+                    <a:srgbClr val="FFFFFF"/>
+                  </a:solidFill>
+                  <a:latin typeface="Calibri"/>
+                </a:rPr>
+                <a:t>scale to 0–1 (fixed range)</a:t>
+              </a:r>
+            </a:p>
+          </p:txBody>
+        </p:sp>
+        <p:cxnSp>
+          <p:nvCxnSpPr>
+            <p:cNvPr id="9" name="Connector 8"/>
+            <p:cNvCxnSpPr/>
+            <p:nvPr/>
+          </p:nvCxnSpPr>
+          <p:spPr>
+            <a:xfrm>
+              <a:off x="5120640" y="2194560"/>
+              <a:ext cx="182880" cy="0"/>
+            </a:xfrm>
+            <a:prstGeom prst="line">
+              <a:avLst/>
+            </a:prstGeom>
+            <a:ln w="19050">
+              <a:solidFill>
+                <a:srgbClr val="1E1E1E"/>
+              </a:solidFill>
+              <a:tailEnd type="triangle" w="med" len="med"/>
+            </a:ln>
+          </p:spPr>
+          <p:style>
+            <a:lnRef idx="2">
+              <a:schemeClr val="accent1"/>
+            </a:lnRef>
+            <a:fillRef idx="0">
+              <a:schemeClr val="accent1"/>
+            </a:fillRef>
+            <a:effectRef idx="1">
+              <a:schemeClr val="accent1"/>
+            </a:effectRef>
+            <a:fontRef idx="minor">
+              <a:schemeClr val="tx1"/>
+            </a:fontRef>
+          </p:style>
+        </p:cxnSp>
+        <p:sp>
+          <p:nvSpPr>
+            <p:cNvPr id="10" name="Rounded Rectangle 9"/>
+            <p:cNvSpPr/>
+            <p:nvPr/>
+          </p:nvSpPr>
+          <p:spPr>
+            <a:xfrm>
+              <a:off x="5303520" y="1920240"/>
+              <a:ext cx="960120" cy="548640"/>
             </a:xfrm>
             <a:prstGeom prst="roundRect">
               <a:avLst/>
@@ -28194,7 +28558,7 @@
             <a:p>
               <a:pPr algn="ctr"/>
               <a:r>
-                <a:rPr sz="1050" b="0">
+                <a:rPr sz="1000" b="0">
                   <a:solidFill>
                     <a:srgbClr val="FFFFFF"/>
                   </a:solidFill>
@@ -28207,14 +28571,14 @@
         </p:sp>
         <p:cxnSp>
           <p:nvCxnSpPr>
-            <p:cNvPr id="9" name="Connector 8"/>
+            <p:cNvPr id="11" name="Connector 10"/>
             <p:cNvCxnSpPr/>
             <p:nvPr/>
           </p:nvCxnSpPr>
           <p:spPr>
             <a:xfrm>
-              <a:off x="5257800" y="2386584"/>
-              <a:ext cx="228600" cy="0"/>
+              <a:off x="6263640" y="2194560"/>
+              <a:ext cx="182880" cy="0"/>
             </a:xfrm>
             <a:prstGeom prst="line">
               <a:avLst/>
@@ -28243,14 +28607,14 @@
         </p:cxnSp>
         <p:sp>
           <p:nvSpPr>
-            <p:cNvPr id="10" name="Rounded Rectangle 9"/>
+            <p:cNvPr id="12" name="Rounded Rectangle 11"/>
             <p:cNvSpPr/>
             <p:nvPr/>
           </p:nvSpPr>
           <p:spPr>
             <a:xfrm>
-              <a:off x="5486400" y="2103120"/>
-              <a:ext cx="1691640" cy="566928"/>
+              <a:off x="6446520" y="1920240"/>
+              <a:ext cx="1463040" cy="548640"/>
             </a:xfrm>
             <a:prstGeom prst="roundRect">
               <a:avLst/>
@@ -28283,7 +28647,7 @@
             <a:p>
               <a:pPr algn="ctr"/>
               <a:r>
-                <a:rPr sz="1050" b="0">
+                <a:rPr sz="1000" b="0">
                   <a:solidFill>
                     <a:srgbClr val="FFFFFF"/>
                   </a:solidFill>
@@ -28296,14 +28660,14 @@
         </p:sp>
         <p:cxnSp>
           <p:nvCxnSpPr>
-            <p:cNvPr id="11" name="Connector 10"/>
+            <p:cNvPr id="13" name="Connector 12"/>
             <p:cNvCxnSpPr/>
             <p:nvPr/>
           </p:nvCxnSpPr>
           <p:spPr>
             <a:xfrm>
-              <a:off x="7178040" y="2386584"/>
-              <a:ext cx="228600" cy="0"/>
+              <a:off x="7909560" y="2194560"/>
+              <a:ext cx="182880" cy="0"/>
             </a:xfrm>
             <a:prstGeom prst="line">
               <a:avLst/>
@@ -28332,14 +28696,14 @@
         </p:cxnSp>
         <p:sp>
           <p:nvSpPr>
-            <p:cNvPr id="12" name="Rounded Rectangle 11"/>
+            <p:cNvPr id="14" name="Rounded Rectangle 13"/>
             <p:cNvSpPr/>
             <p:nvPr/>
           </p:nvSpPr>
           <p:spPr>
             <a:xfrm>
-              <a:off x="7406640" y="2103120"/>
-              <a:ext cx="1828800" cy="566928"/>
+              <a:off x="8092440" y="1920240"/>
+              <a:ext cx="1600200" cy="548640"/>
             </a:xfrm>
             <a:prstGeom prst="roundRect">
               <a:avLst/>
@@ -28372,27 +28736,27 @@
             <a:p>
               <a:pPr algn="ctr"/>
               <a:r>
-                <a:rPr sz="1050" b="0">
+                <a:rPr sz="1000" b="0">
                   <a:solidFill>
                     <a:srgbClr val="FFFFFF"/>
                   </a:solidFill>
                   <a:latin typeface="Calibri"/>
                 </a:rPr>
-                <a:t>threshold (chosen on validation data)</a:t>
+                <a:t>threshold (picked on validation images)</a:t>
               </a:r>
             </a:p>
           </p:txBody>
         </p:sp>
         <p:cxnSp>
           <p:nvCxnSpPr>
-            <p:cNvPr id="13" name="Connector 12"/>
+            <p:cNvPr id="15" name="Connector 14"/>
             <p:cNvCxnSpPr/>
             <p:nvPr/>
           </p:nvCxnSpPr>
           <p:spPr>
             <a:xfrm>
-              <a:off x="9235440" y="2386584"/>
-              <a:ext cx="228600" cy="0"/>
+              <a:off x="9692640" y="2194560"/>
+              <a:ext cx="182879" cy="0"/>
             </a:xfrm>
             <a:prstGeom prst="line">
               <a:avLst/>
@@ -28421,14 +28785,14 @@
         </p:cxnSp>
         <p:sp>
           <p:nvSpPr>
-            <p:cNvPr id="14" name="Rounded Rectangle 13"/>
+            <p:cNvPr id="16" name="Rounded Rectangle 15"/>
             <p:cNvSpPr/>
             <p:nvPr/>
           </p:nvSpPr>
           <p:spPr>
             <a:xfrm>
-              <a:off x="9464040" y="2103120"/>
-              <a:ext cx="1600200" cy="566928"/>
+              <a:off x="9875519" y="1920240"/>
+              <a:ext cx="1417320" cy="548640"/>
             </a:xfrm>
             <a:prstGeom prst="roundRect">
               <a:avLst/>
@@ -28461,7 +28825,7 @@
             <a:p>
               <a:pPr algn="ctr"/>
               <a:r>
-                <a:rPr sz="1050" b="0">
+                <a:rPr sz="1000" b="0">
                   <a:solidFill>
                     <a:srgbClr val="1E1E1E"/>
                   </a:solidFill>
@@ -28475,14 +28839,14 @@
       </p:grpSp>
       <p:sp>
         <p:nvSpPr>
-          <p:cNvPr id="15" name="Rounded Rectangle 14"/>
+          <p:cNvPr id="17" name="Rounded Rectangle 16"/>
           <p:cNvSpPr/>
           <p:nvPr/>
         </p:nvSpPr>
         <p:spPr>
           <a:xfrm>
-            <a:off x="685800" y="3246120"/>
-            <a:ext cx="10835640" cy="1600200"/>
+            <a:off x="685800" y="2907792"/>
+            <a:ext cx="10835640" cy="1481328"/>
           </a:xfrm>
           <a:prstGeom prst="roundRect">
             <a:avLst>
@@ -28523,14 +28887,14 @@
       </p:sp>
       <p:sp>
         <p:nvSpPr>
-          <p:cNvPr id="16" name="TextBox 15"/>
+          <p:cNvPr id="18" name="TextBox 17"/>
           <p:cNvSpPr txBox="1"/>
           <p:nvPr/>
         </p:nvSpPr>
         <p:spPr>
           <a:xfrm>
-            <a:off x="804672" y="3319272"/>
-            <a:ext cx="1920240" cy="1463040"/>
+            <a:off x="804672" y="2962656"/>
+            <a:ext cx="1828800" cy="1371600"/>
           </a:xfrm>
           <a:prstGeom prst="rect">
             <a:avLst/>
@@ -28571,35 +28935,35 @@
                 </a:solidFill>
                 <a:latin typeface="Calibri"/>
               </a:rPr>
-              <a:t>repeated 28,000 times</a:t>
+              <a:t>28,000 steps, one image per step</a:t>
             </a:r>
           </a:p>
         </p:txBody>
       </p:sp>
       <p:grpSp>
         <p:nvGrpSpPr>
-          <p:cNvPr id="17" name="Group 16"/>
+          <p:cNvPr id="19" name="Group 18"/>
           <p:cNvGrpSpPr/>
           <p:nvPr/>
         </p:nvGrpSpPr>
         <p:grpSpPr>
           <a:xfrm>
-            <a:off x="2697480" y="3493008"/>
-            <a:ext cx="7498080" cy="1115568"/>
-            <a:chOff x="2697480" y="3493008"/>
-            <a:chExt cx="7498080" cy="1115568"/>
+            <a:off x="2697480" y="3108960"/>
+            <a:ext cx="8458199" cy="1097279"/>
+            <a:chOff x="2697480" y="3108960"/>
+            <a:chExt cx="8458199" cy="1097279"/>
           </a:xfrm>
         </p:grpSpPr>
         <p:sp>
           <p:nvSpPr>
-            <p:cNvPr id="18" name="Rounded Rectangle 17"/>
+            <p:cNvPr id="20" name="Rounded Rectangle 19"/>
             <p:cNvSpPr/>
             <p:nvPr/>
           </p:nvSpPr>
           <p:spPr>
             <a:xfrm>
-              <a:off x="2697480" y="3493008"/>
-              <a:ext cx="1691640" cy="457200"/>
+              <a:off x="2697480" y="3108960"/>
+              <a:ext cx="1554480" cy="457200"/>
             </a:xfrm>
             <a:prstGeom prst="roundRect">
               <a:avLst/>
@@ -28632,7 +28996,7 @@
             <a:p>
               <a:pPr algn="ctr"/>
               <a:r>
-                <a:rPr sz="1050" b="0">
+                <a:rPr sz="1000" b="0">
                   <a:solidFill>
                     <a:srgbClr val="FFFFFF"/>
                   </a:solidFill>
@@ -28645,14 +29009,14 @@
         </p:sp>
         <p:sp>
           <p:nvSpPr>
-            <p:cNvPr id="19" name="Rounded Rectangle 18"/>
+            <p:cNvPr id="21" name="Rounded Rectangle 20"/>
             <p:cNvSpPr/>
             <p:nvPr/>
           </p:nvSpPr>
           <p:spPr>
             <a:xfrm>
-              <a:off x="2697480" y="4151376"/>
-              <a:ext cx="1691640" cy="457200"/>
+              <a:off x="2697480" y="3749039"/>
+              <a:ext cx="1554480" cy="457200"/>
             </a:xfrm>
             <a:prstGeom prst="roundRect">
               <a:avLst/>
@@ -28685,7 +29049,7 @@
             <a:p>
               <a:pPr algn="ctr"/>
               <a:r>
-                <a:rPr sz="1050" b="0">
+                <a:rPr sz="1000" b="0">
                   <a:solidFill>
                     <a:srgbClr val="1E1E1E"/>
                   </a:solidFill>
@@ -28698,14 +29062,14 @@
         </p:sp>
         <p:sp>
           <p:nvSpPr>
-            <p:cNvPr id="20" name="Rounded Rectangle 19"/>
+            <p:cNvPr id="22" name="Rounded Rectangle 21"/>
             <p:cNvSpPr/>
             <p:nvPr/>
           </p:nvSpPr>
           <p:spPr>
             <a:xfrm>
-              <a:off x="4800600" y="3593591"/>
-              <a:ext cx="2377440" cy="822960"/>
+              <a:off x="4572000" y="3200400"/>
+              <a:ext cx="2103120" cy="914400"/>
             </a:xfrm>
             <a:prstGeom prst="roundRect">
               <a:avLst/>
@@ -28738,7 +29102,7 @@
             <a:p>
               <a:pPr algn="ctr"/>
               <a:r>
-                <a:rPr sz="1050" b="1">
+                <a:rPr sz="1000" b="1">
                   <a:solidFill>
                     <a:srgbClr val="FFFFFF"/>
                   </a:solidFill>
@@ -28750,27 +29114,27 @@
             <a:p>
               <a:pPr algn="ctr"/>
               <a:r>
-                <a:rPr sz="1050" b="0">
+                <a:rPr sz="1000" b="0">
                   <a:solidFill>
                     <a:srgbClr val="FFFFFF"/>
                   </a:solidFill>
                   <a:latin typeface="Calibri"/>
                 </a:rPr>
-                <a:t>how wrong the model is (no class weighting ⑧)</a:t>
+                <a:t>how wrong the model is; no class weighting ⑧</a:t>
               </a:r>
             </a:p>
           </p:txBody>
         </p:sp>
         <p:cxnSp>
           <p:nvCxnSpPr>
-            <p:cNvPr id="21" name="Connector 20"/>
+            <p:cNvPr id="23" name="Connector 22"/>
             <p:cNvCxnSpPr/>
             <p:nvPr/>
           </p:nvCxnSpPr>
           <p:spPr>
             <a:xfrm>
-              <a:off x="4389120" y="3721608"/>
-              <a:ext cx="411480" cy="182879"/>
+              <a:off x="4251960" y="3337560"/>
+              <a:ext cx="320040" cy="182880"/>
             </a:xfrm>
             <a:prstGeom prst="line">
               <a:avLst/>
@@ -28799,14 +29163,14 @@
         </p:cxnSp>
         <p:cxnSp>
           <p:nvCxnSpPr>
-            <p:cNvPr id="22" name="Connector 21"/>
+            <p:cNvPr id="24" name="Connector 23"/>
             <p:cNvCxnSpPr/>
             <p:nvPr/>
           </p:nvCxnSpPr>
           <p:spPr>
             <a:xfrm flipV="1">
-              <a:off x="4389120" y="4105656"/>
-              <a:ext cx="411480" cy="274320"/>
+              <a:off x="4251960" y="3794760"/>
+              <a:ext cx="320040" cy="182879"/>
             </a:xfrm>
             <a:prstGeom prst="line">
               <a:avLst/>
@@ -28835,14 +29199,14 @@
         </p:cxnSp>
         <p:sp>
           <p:nvSpPr>
-            <p:cNvPr id="23" name="Rounded Rectangle 22"/>
+            <p:cNvPr id="25" name="Rounded Rectangle 24"/>
             <p:cNvSpPr/>
             <p:nvPr/>
           </p:nvSpPr>
           <p:spPr>
             <a:xfrm>
-              <a:off x="7589520" y="3593591"/>
-              <a:ext cx="2606040" cy="822960"/>
+              <a:off x="6995159" y="3200400"/>
+              <a:ext cx="2057400" cy="914400"/>
             </a:xfrm>
             <a:prstGeom prst="roundRect">
               <a:avLst/>
@@ -28875,7 +29239,7 @@
             <a:p>
               <a:pPr algn="ctr"/>
               <a:r>
-                <a:rPr sz="1050" b="1">
+                <a:rPr sz="1000" b="1">
                   <a:solidFill>
                     <a:srgbClr val="FFFFFF"/>
                   </a:solidFill>
@@ -28887,27 +29251,27 @@
             <a:p>
               <a:pPr algn="ctr"/>
               <a:r>
-                <a:rPr sz="1050" b="0">
+                <a:rPr sz="1000" b="0">
                   <a:solidFill>
                     <a:srgbClr val="FFFFFF"/>
                   </a:solidFill>
                   <a:latin typeface="Calibri"/>
                 </a:rPr>
-                <a:t>nudges all 593,842 weights to reduce the loss</a:t>
+                <a:t>nudges all 593,842 numbers to lower the loss</a:t>
               </a:r>
             </a:p>
           </p:txBody>
         </p:sp>
         <p:cxnSp>
           <p:nvCxnSpPr>
-            <p:cNvPr id="24" name="Connector 23"/>
+            <p:cNvPr id="26" name="Connector 25"/>
             <p:cNvCxnSpPr/>
             <p:nvPr/>
           </p:nvCxnSpPr>
           <p:spPr>
             <a:xfrm>
-              <a:off x="7178040" y="4005072"/>
-              <a:ext cx="411480" cy="0"/>
+              <a:off x="6675120" y="3657600"/>
+              <a:ext cx="320039" cy="0"/>
             </a:xfrm>
             <a:prstGeom prst="line">
               <a:avLst/>
@@ -28934,17 +29298,118 @@
             </a:fontRef>
           </p:style>
         </p:cxnSp>
+        <p:sp>
+          <p:nvSpPr>
+            <p:cNvPr id="27" name="Rounded Rectangle 26"/>
+            <p:cNvSpPr/>
+            <p:nvPr/>
+          </p:nvSpPr>
+          <p:spPr>
+            <a:xfrm>
+              <a:off x="9372599" y="3200400"/>
+              <a:ext cx="1783080" cy="914400"/>
+            </a:xfrm>
+            <a:prstGeom prst="roundRect">
+              <a:avLst/>
+            </a:prstGeom>
+            <a:solidFill>
+              <a:srgbClr val="2E4A7D"/>
+            </a:solidFill>
+            <a:ln>
+              <a:noFill/>
+            </a:ln>
+            <a:effectLst/>
+          </p:spPr>
+          <p:style>
+            <a:lnRef idx="1">
+              <a:schemeClr val="accent1"/>
+            </a:lnRef>
+            <a:fillRef idx="3">
+              <a:schemeClr val="accent1"/>
+            </a:fillRef>
+            <a:effectRef idx="2">
+              <a:schemeClr val="accent1"/>
+            </a:effectRef>
+            <a:fontRef idx="minor">
+              <a:schemeClr val="lt1"/>
+            </a:fontRef>
+          </p:style>
+          <p:txBody>
+            <a:bodyPr rtlCol="0" anchor="ctr" wrap="square" lIns="36576" rIns="36576" tIns="9144" bIns="9144"/>
+            <a:lstStyle/>
+            <a:p>
+              <a:pPr algn="ctr"/>
+              <a:r>
+                <a:rPr sz="1000" b="1">
+                  <a:solidFill>
+                    <a:srgbClr val="FFFFFF"/>
+                  </a:solidFill>
+                  <a:latin typeface="Calibri"/>
+                </a:rPr>
+                <a:t>Every 1,400 steps</a:t>
+              </a:r>
+            </a:p>
+            <a:p>
+              <a:pPr algn="ctr"/>
+              <a:r>
+                <a:rPr sz="1000" b="0">
+                  <a:solidFill>
+                    <a:srgbClr val="FFFFFF"/>
+                  </a:solidFill>
+                  <a:latin typeface="Calibri"/>
+                </a:rPr>
+                <a:t>check on 150 validation images; keep the best version</a:t>
+              </a:r>
+            </a:p>
+          </p:txBody>
+        </p:sp>
+        <p:cxnSp>
+          <p:nvCxnSpPr>
+            <p:cNvPr id="28" name="Connector 27"/>
+            <p:cNvCxnSpPr/>
+            <p:nvPr/>
+          </p:nvCxnSpPr>
+          <p:spPr>
+            <a:xfrm>
+              <a:off x="9052559" y="3657600"/>
+              <a:ext cx="320040" cy="0"/>
+            </a:xfrm>
+            <a:prstGeom prst="line">
+              <a:avLst/>
+            </a:prstGeom>
+            <a:ln w="19050">
+              <a:solidFill>
+                <a:srgbClr val="1E1E1E"/>
+              </a:solidFill>
+              <a:tailEnd type="triangle" w="med" len="med"/>
+            </a:ln>
+          </p:spPr>
+          <p:style>
+            <a:lnRef idx="2">
+              <a:schemeClr val="accent1"/>
+            </a:lnRef>
+            <a:fillRef idx="0">
+              <a:schemeClr val="accent1"/>
+            </a:fillRef>
+            <a:effectRef idx="1">
+              <a:schemeClr val="accent1"/>
+            </a:effectRef>
+            <a:fontRef idx="minor">
+              <a:schemeClr val="tx1"/>
+            </a:fontRef>
+          </p:style>
+        </p:cxnSp>
       </p:grpSp>
       <p:sp>
         <p:nvSpPr>
-          <p:cNvPr id="25" name="Rounded Rectangle 24"/>
+          <p:cNvPr id="29" name="Rounded Rectangle 28"/>
           <p:cNvSpPr/>
           <p:nvPr/>
         </p:nvSpPr>
         <p:spPr>
           <a:xfrm>
-            <a:off x="685800" y="5029200"/>
-            <a:ext cx="10835640" cy="960120"/>
+            <a:off x="685800" y="4517136"/>
+            <a:ext cx="10835640" cy="1645920"/>
           </a:xfrm>
           <a:prstGeom prst="roundRect">
             <a:avLst>
@@ -28985,14 +29450,14 @@
       </p:sp>
       <p:sp>
         <p:nvSpPr>
-          <p:cNvPr id="26" name="TextBox 25"/>
+          <p:cNvPr id="30" name="TextBox 29"/>
           <p:cNvSpPr txBox="1"/>
           <p:nvPr/>
         </p:nvSpPr>
         <p:spPr>
           <a:xfrm>
-            <a:off x="868680" y="5120640"/>
-            <a:ext cx="10515600" cy="822960"/>
+            <a:off x="868680" y="4608576"/>
+            <a:ext cx="10515600" cy="1499616"/>
           </a:xfrm>
           <a:prstGeom prst="rect">
             <a:avLst/>
@@ -29017,7 +29482,7 @@
                 </a:solidFill>
                 <a:latin typeface="Calibri"/>
               </a:rPr>
-              <a:t>Which parts actually matter? </a:t>
+              <a:t>How it is scored: </a:t>
             </a:r>
             <a:r>
               <a:rPr sz="1300" b="0">
@@ -29026,7 +29491,7 @@
                 </a:solidFill>
                 <a:latin typeface="Calibri"/>
               </a:rPr>
-              <a:t>Removing ①②③ (strips, shortcuts, attention) changes F1 from 0.660 to 0.658 — not significant (3 runs each, p = 0.64).</a:t>
+              <a:t>109 test images labelled by a human expert; F1 at the best threshold (the standard for this benchmark); 3 runs each, mean ± spread.</a:t>
             </a:r>
           </a:p>
           <a:p>
@@ -29042,7 +29507,7 @@
                 </a:solidFill>
                 <a:latin typeface="Calibri"/>
               </a:rPr>
-              <a:t>So the model's strength comes from ④–⑨: </a:t>
+              <a:t>Our model 0.6603 ± 0.0040</a:t>
             </a:r>
             <a:r>
               <a:rPr sz="1300" b="0">
@@ -29051,7 +29516,57 @@
                 </a:solidFill>
                 <a:latin typeface="Calibri"/>
               </a:rPr>
-              <a:t>normalisation, raw output scores, the Dice loss, same padding, no class weighting, and its size and training setup.</a:t>
+              <a:t>  vs  Akeret's tf_unet 0.5482 ± 0.0139  →  about +0.11.</a:t>
+            </a:r>
+          </a:p>
+          <a:p>
+            <a:pPr algn="l">
+              <a:spcAft>
+                <a:spcPts val="600"/>
+              </a:spcAft>
+            </a:pPr>
+            <a:r>
+              <a:rPr sz="1300" b="1">
+                <a:solidFill>
+                  <a:srgbClr val="E31837"/>
+                </a:solidFill>
+                <a:latin typeface="Calibri"/>
+              </a:rPr>
+              <a:t>Which parts matter? </a:t>
+            </a:r>
+            <a:r>
+              <a:rPr sz="1300" b="0">
+                <a:solidFill>
+                  <a:srgbClr val="1E1E1E"/>
+                </a:solidFill>
+                <a:latin typeface="Calibri"/>
+              </a:rPr>
+              <a:t>Removing ①②③ gives 0.6585 — not significant (p = 0.64). Removing ④ as well gives 0.6495 — also not significant (p = 0.48).</a:t>
+            </a:r>
+          </a:p>
+          <a:p>
+            <a:pPr algn="l">
+              <a:spcAft>
+                <a:spcPts val="600"/>
+              </a:spcAft>
+            </a:pPr>
+            <a:r>
+              <a:rPr sz="1300" b="1">
+                <a:solidFill>
+                  <a:srgbClr val="1E1E1E"/>
+                </a:solidFill>
+                <a:latin typeface="Calibri"/>
+              </a:rPr>
+              <a:t>So the gain over tf_unet sits mainly in ⑤ ⑥ ⑦ ⑨ </a:t>
+            </a:r>
+            <a:r>
+              <a:rPr sz="1300" b="0">
+                <a:solidFill>
+                  <a:srgbClr val="1E1E1E"/>
+                </a:solidFill>
+                <a:latin typeface="Calibri"/>
+              </a:rPr>
+              <a:t>(raw output, Dice loss, same padding, size and training setup) — not yet tested one at a time.</a:t>
             </a:r>
           </a:p>
         </p:txBody>

</xml_diff>